<commit_message>
feat: wire real NotebookLM URL into training package
Replace [placeholder URL] with live notebook link across slide 20
outline, rebuilt slides.pptx, facilitator guide closing script, and
README distribution section. URL also becomes a hyperlink on the
wrap slide.

Notebook: https://notebooklm.google.com/notebook/977f6c56-73d1-4c8a-b873-de51c86634d7

Co-Authored-By: Claude Opus 4.7 (1M context) <noreply@anthropic.com>
</commit_message>
<xml_diff>
--- a/training/make-chatgpt-your-slave/slides/slides.pptx
+++ b/training/make-chatgpt-your-slave/slides/slides.pptx
@@ -5944,7 +5944,9 @@
       </p:sp>
       <p:sp>
         <p:nvSpPr>
-          <p:cNvPr id="5" name="Text 3"/>
+          <p:cNvPr id="5" name="Text 3">
+            <a:hlinkClick r:id="rId1" tooltip=""/>
+          </p:cNvPr>
           <p:cNvSpPr/>
           <p:nvPr/>
         </p:nvSpPr>
@@ -5967,17 +5969,24 @@
               <a:buNone/>
             </a:pPr>
             <a:r>
-              <a:rPr lang="en-US" sz="2000" i="1" dirty="0">
+              <a:rPr lang="en-US" sz="1600" u="sng" dirty="0">
                 <a:solidFill>
                   <a:srgbClr val="141414"/>
                 </a:solidFill>
                 <a:latin typeface="Helvetica Neue" pitchFamily="34" charset="0"/>
                 <a:ea typeface="Helvetica Neue" pitchFamily="34" charset="-122"/>
                 <a:cs typeface="Helvetica Neue" pitchFamily="34" charset="-120"/>
-              </a:rPr>
-              <a:t>[placeholder URL]</a:t>
-            </a:r>
-            <a:endParaRPr lang="en-US" sz="2000" dirty="0"/>
+                <a:hlinkClick r:id="rId1" invalidUrl="" action="" tgtFrame="" tooltip="" history="1" highlightClick="0" endSnd="0">
+                  <a:extLst>
+                    <a:ext uri="{A12FA001-AC4F-418D-AE19-62706E023703}">
+                      <ahyp:hlinkClr xmlns:ahyp="http://schemas.microsoft.com/office/drawing/2018/hyperlinkcolor" val="tx"/>
+                    </a:ext>
+                  </a:extLst>
+                </a:hlinkClick>
+              </a:rPr>
+              <a:t>notebooklm.google.com/notebook/977f6c56</a:t>
+            </a:r>
+            <a:endParaRPr lang="en-US" sz="1600" dirty="0"/>
           </a:p>
         </p:txBody>
       </p:sp>

</xml_diff>

<commit_message>
feat: wire real NotebookLM URL into training package (#3)
Replace [placeholder URL] with live notebook link across slide 20
outline, rebuilt slides.pptx, facilitator guide closing script, and
README distribution section. URL also becomes a hyperlink on the
wrap slide.

Notebook: https://notebooklm.google.com/notebook/977f6c56-73d1-4c8a-b873-de51c86634d7

Co-authored-by: Claude Opus 4.7 (1M context) <noreply@anthropic.com>
</commit_message>
<xml_diff>
--- a/training/make-chatgpt-your-slave/slides/slides.pptx
+++ b/training/make-chatgpt-your-slave/slides/slides.pptx
@@ -5944,7 +5944,9 @@
       </p:sp>
       <p:sp>
         <p:nvSpPr>
-          <p:cNvPr id="5" name="Text 3"/>
+          <p:cNvPr id="5" name="Text 3">
+            <a:hlinkClick r:id="rId1" tooltip=""/>
+          </p:cNvPr>
           <p:cNvSpPr/>
           <p:nvPr/>
         </p:nvSpPr>
@@ -5967,17 +5969,24 @@
               <a:buNone/>
             </a:pPr>
             <a:r>
-              <a:rPr lang="en-US" sz="2000" i="1" dirty="0">
+              <a:rPr lang="en-US" sz="1600" u="sng" dirty="0">
                 <a:solidFill>
                   <a:srgbClr val="141414"/>
                 </a:solidFill>
                 <a:latin typeface="Helvetica Neue" pitchFamily="34" charset="0"/>
                 <a:ea typeface="Helvetica Neue" pitchFamily="34" charset="-122"/>
                 <a:cs typeface="Helvetica Neue" pitchFamily="34" charset="-120"/>
-              </a:rPr>
-              <a:t>[placeholder URL]</a:t>
-            </a:r>
-            <a:endParaRPr lang="en-US" sz="2000" dirty="0"/>
+                <a:hlinkClick r:id="rId1" invalidUrl="" action="" tgtFrame="" tooltip="" history="1" highlightClick="0" endSnd="0">
+                  <a:extLst>
+                    <a:ext uri="{A12FA001-AC4F-418D-AE19-62706E023703}">
+                      <ahyp:hlinkClr xmlns:ahyp="http://schemas.microsoft.com/office/drawing/2018/hyperlinkcolor" val="tx"/>
+                    </a:ext>
+                  </a:extLst>
+                </a:hlinkClick>
+              </a:rPr>
+              <a:t>notebooklm.google.com/notebook/977f6c56</a:t>
+            </a:r>
+            <a:endParaRPr lang="en-US" sz="1600" dirty="0"/>
           </a:p>
         </p:txBody>
       </p:sp>

</xml_diff>